<commit_message>
Update PowerPoint slide deck to match exact user presentation specifications
</commit_message>
<xml_diff>
--- a/TeamName_KLA_PS01.pptx
+++ b/TeamName_KLA_PS01.pptx
@@ -3148,8 +3148,8 @@
         </p:nvSpPr>
         <p:spPr>
           <a:xfrm>
-            <a:off x="914400" y="1645920"/>
-            <a:ext cx="10362895" cy="2286000"/>
+            <a:off x="731520" y="1097280"/>
+            <a:ext cx="10728655" cy="2011680"/>
           </a:xfrm>
           <a:prstGeom prst="rect">
             <a:avLst/>
@@ -3171,7 +3171,7 @@
               </a:defRPr>
             </a:pPr>
             <a:r>
-              <a:t>Physics-Guided Deep Unfolding Network for Joint Semiconductor Wafer Inspection Image Restoration</a:t>
+              <a:t>Physics-Guided Deep Unfolding Network (Physics-DUN) for Joint Semiconductor Wafer Restoration</a:t>
             </a:r>
           </a:p>
         </p:txBody>
@@ -3184,8 +3184,8 @@
         </p:nvSpPr>
         <p:spPr>
           <a:xfrm>
-            <a:off x="914400" y="4114800"/>
-            <a:ext cx="10362895" cy="1828800"/>
+            <a:off x="731520" y="3108960"/>
+            <a:ext cx="10728655" cy="1097280"/>
           </a:xfrm>
           <a:prstGeom prst="rect">
             <a:avLst/>
@@ -3199,7 +3199,7 @@
           <a:lstStyle/>
           <a:p>
             <a:pPr algn="ctr">
-              <a:defRPr sz="2000">
+              <a:defRPr sz="2000" i="1">
                 <a:solidFill>
                   <a:srgbClr val="C8DCFF"/>
                 </a:solidFill>
@@ -3207,11 +3207,75 @@
               </a:defRPr>
             </a:pPr>
             <a:r>
-              <a:t>KLA AI Hackathon - Problem Statement 1 Submission</a:t>
-            </a:r>
-            <a:br/>
-            <a:r>
-              <a:t>Team: Team KLA_PS01  |  Lead: Ansh Katiyar</a:t>
+              <a:t>AI-Based Image Restoration for High-Throughput Wafer Metrology &amp; Defect Inspection</a:t>
+            </a:r>
+          </a:p>
+        </p:txBody>
+      </p:sp>
+      <p:sp>
+        <p:nvSpPr>
+          <p:cNvPr id="5" name="TextBox 4"/>
+          <p:cNvSpPr txBox="1"/>
+          <p:nvPr/>
+        </p:nvSpPr>
+        <p:spPr>
+          <a:xfrm>
+            <a:off x="731520" y="4206240"/>
+            <a:ext cx="10728655" cy="2011680"/>
+          </a:xfrm>
+          <a:prstGeom prst="rect">
+            <a:avLst/>
+          </a:prstGeom>
+          <a:noFill/>
+        </p:spPr>
+        <p:txBody>
+          <a:bodyPr wrap="square">
+            <a:spAutoFit/>
+          </a:bodyPr>
+          <a:lstStyle/>
+          <a:p>
+            <a:pPr algn="ctr">
+              <a:spcAft>
+                <a:spcPts val="800"/>
+              </a:spcAft>
+              <a:defRPr sz="1600" b="1">
+                <a:solidFill>
+                  <a:srgbClr val="FFFFFF"/>
+                </a:solidFill>
+                <a:latin typeface="Arial"/>
+              </a:defRPr>
+            </a:pPr>
+            <a:r>
+              <a:t>Problem Statement: Problem Statement 01 — AI-Based Restoration of Degraded Images (KLA Track)</a:t>
+            </a:r>
+          </a:p>
+          <a:p>
+            <a:pPr algn="ctr">
+              <a:spcAft>
+                <a:spcPts val="800"/>
+              </a:spcAft>
+              <a:defRPr sz="1600">
+                <a:solidFill>
+                  <a:srgbClr val="FFFFFF"/>
+                </a:solidFill>
+                <a:latin typeface="Arial"/>
+              </a:defRPr>
+            </a:pPr>
+            <a:r>
+              <a:t>Team Name: Team KLA_PS01  |  Team Lead: Ansh Katiyar</a:t>
+            </a:r>
+          </a:p>
+          <a:p>
+            <a:pPr algn="ctr">
+              <a:defRPr sz="1600">
+                <a:solidFill>
+                  <a:srgbClr val="C8DCFF"/>
+                </a:solidFill>
+                <a:latin typeface="Arial"/>
+              </a:defRPr>
+            </a:pPr>
+            <a:r>
+              <a:t>Institution: Vellore Institute of Technology (VIT Vellore)</a:t>
             </a:r>
           </a:p>
         </p:txBody>
@@ -3310,7 +3374,7 @@
               </a:defRPr>
             </a:pPr>
             <a:r>
-              <a:t>Problem Statement &amp; WAFER Inspection Challenges</a:t>
+              <a:t>Problem Statement &amp; Industrial Wafer Inspection Challenges</a:t>
             </a:r>
           </a:p>
         </p:txBody>
@@ -3323,8 +3387,8 @@
         </p:nvSpPr>
         <p:spPr>
           <a:xfrm>
-            <a:off x="457200" y="1371600"/>
-            <a:ext cx="11277295" cy="5029200"/>
+            <a:off x="457200" y="1280160"/>
+            <a:ext cx="11277295" cy="5120640"/>
           </a:xfrm>
           <a:prstGeom prst="rect">
             <a:avLst/>
@@ -3343,20 +3407,113 @@
               </a:spcAft>
             </a:pPr>
             <a:r>
-              <a:rPr b="1" sz="1800">
+              <a:rPr b="1" sz="1600">
                 <a:solidFill>
                   <a:srgbClr val="212529"/>
                 </a:solidFill>
+                <a:latin typeface="Arial"/>
               </a:rPr>
-              <a:t>Industrial Wafer Inspection: </a:t>
-            </a:r>
-            <a:r>
-              <a:rPr sz="1800">
+              <a:t>The Inspection Bottleneck:</a:t>
+            </a:r>
+            <a:r>
+              <a:rPr sz="1600">
                 <a:solidFill>
                   <a:srgbClr val="212529"/>
                 </a:solidFill>
+                <a:latin typeface="Arial"/>
               </a:rPr>
-              <a:t> microscopic wafer scans require sub-pixel accuracy. Nanoscale defects are easily hidden by noise, causing yield-limiting measurement errors.</a:t>
+              <a:t> Microscopic wafer scanning requires sub-pixel fidelity to detect nanoscale yield-limiting defects. Signal degradation causes measurement dropouts and critical false-negative classifications.</a:t>
+            </a:r>
+          </a:p>
+          <a:p>
+            <a:pPr>
+              <a:spcAft>
+                <a:spcPts val="800"/>
+              </a:spcAft>
+            </a:pPr>
+            <a:r>
+              <a:rPr b="1" sz="1600">
+                <a:solidFill>
+                  <a:srgbClr val="212529"/>
+                </a:solidFill>
+                <a:latin typeface="Arial"/>
+              </a:rPr>
+              <a:t>Compounded Physical Degradation Modes:</a:t>
+            </a:r>
+          </a:p>
+          <a:p>
+            <a:pPr lvl="1">
+              <a:spcAft>
+                <a:spcPts val="600"/>
+              </a:spcAft>
+            </a:pPr>
+            <a:r>
+              <a:rPr b="1" sz="1600">
+                <a:solidFill>
+                  <a:srgbClr val="212529"/>
+                </a:solidFill>
+                <a:latin typeface="Arial"/>
+              </a:rPr>
+              <a:t>• Multiplicative Speckle Noise: </a:t>
+            </a:r>
+            <a:r>
+              <a:rPr sz="1600">
+                <a:solidFill>
+                  <a:srgbClr val="212529"/>
+                </a:solidFill>
+                <a:latin typeface="Arial"/>
+              </a:rPr>
+              <a:t>Signal-dependent intensity spread where pixel readings exceed nominal [0.0, 1.0] bounds.</a:t>
+            </a:r>
+          </a:p>
+          <a:p>
+            <a:pPr lvl="1">
+              <a:spcAft>
+                <a:spcPts val="600"/>
+              </a:spcAft>
+            </a:pPr>
+            <a:r>
+              <a:rPr b="1" sz="1600">
+                <a:solidFill>
+                  <a:srgbClr val="212529"/>
+                </a:solidFill>
+                <a:latin typeface="Arial"/>
+              </a:rPr>
+              <a:t>• Optical Gaussian Blur: </a:t>
+            </a:r>
+            <a:r>
+              <a:rPr sz="1600">
+                <a:solidFill>
+                  <a:srgbClr val="212529"/>
+                </a:solidFill>
+                <a:latin typeface="Arial"/>
+              </a:rPr>
+              <a:t>Spatially correlated light scattering that destroys fine line transitions and edge geometry.</a:t>
+            </a:r>
+          </a:p>
+          <a:p>
+            <a:pPr lvl="1">
+              <a:spcAft>
+                <a:spcPts val="1200"/>
+              </a:spcAft>
+            </a:pPr>
+            <a:r>
+              <a:rPr b="1" sz="1600">
+                <a:solidFill>
+                  <a:srgbClr val="212529"/>
+                </a:solidFill>
+                <a:latin typeface="Arial"/>
+              </a:rPr>
+              <a:t>• 2x Spatial Resolution Loss: </a:t>
+            </a:r>
+            <a:r>
+              <a:rPr sz="1600">
+                <a:solidFill>
+                  <a:srgbClr val="212529"/>
+                </a:solidFill>
+                <a:latin typeface="Arial"/>
+              </a:rPr>
+              <a:t>Sensor downsampling (256x256 → 128x128 or 512x512 → 256x256).</a:t>
             </a:r>
           </a:p>
           <a:p>
@@ -3366,112 +3523,22 @@
               </a:spcAft>
             </a:pPr>
             <a:r>
-              <a:rPr b="1" sz="1800">
+              <a:rPr b="1" sz="1600">
                 <a:solidFill>
                   <a:srgbClr val="212529"/>
                 </a:solidFill>
+                <a:latin typeface="Arial"/>
               </a:rPr>
-              <a:t>Compounded Physical Degradation: </a:t>
-            </a:r>
-            <a:r>
-              <a:rPr sz="1800">
+              <a:t>Mission:</a:t>
+            </a:r>
+            <a:r>
+              <a:rPr sz="1600">
                 <a:solidFill>
                   <a:srgbClr val="212529"/>
                 </a:solidFill>
+                <a:latin typeface="Arial"/>
               </a:rPr>
-              <a:t> Images suffer from three simultaneous signal-degrading phenomena:</a:t>
-            </a:r>
-          </a:p>
-          <a:p>
-            <a:pPr lvl="1">
-              <a:spcAft>
-                <a:spcPts val="1200"/>
-              </a:spcAft>
-            </a:pPr>
-            <a:r>
-              <a:rPr b="1" sz="1800">
-                <a:solidFill>
-                  <a:srgbClr val="212529"/>
-                </a:solidFill>
-              </a:rPr>
-              <a:t>1. Multiplicative Speckle Noise: </a:t>
-            </a:r>
-            <a:r>
-              <a:rPr sz="1800">
-                <a:solidFill>
-                  <a:srgbClr val="212529"/>
-                </a:solidFill>
-              </a:rPr>
-              <a:t> Grainy noise scaling with local intensity, pushing degraded gray levels outside standard [0.0, 1.0] bounds.</a:t>
-            </a:r>
-          </a:p>
-          <a:p>
-            <a:pPr lvl="1">
-              <a:spcAft>
-                <a:spcPts val="1200"/>
-              </a:spcAft>
-            </a:pPr>
-            <a:r>
-              <a:rPr b="1" sz="1800">
-                <a:solidFill>
-                  <a:srgbClr val="212529"/>
-                </a:solidFill>
-              </a:rPr>
-              <a:t>2. Gaussian Blur: </a:t>
-            </a:r>
-            <a:r>
-              <a:rPr sz="1800">
-                <a:solidFill>
-                  <a:srgbClr val="212529"/>
-                </a:solidFill>
-              </a:rPr>
-              <a:t> Spatially correlated light scattering that destroys edge sharpness and geometric transitions.</a:t>
-            </a:r>
-          </a:p>
-          <a:p>
-            <a:pPr lvl="1">
-              <a:spcAft>
-                <a:spcPts val="1200"/>
-              </a:spcAft>
-            </a:pPr>
-            <a:r>
-              <a:rPr b="1" sz="1800">
-                <a:solidFill>
-                  <a:srgbClr val="212529"/>
-                </a:solidFill>
-              </a:rPr>
-              <a:t>3. Spatial Resolution Loss: </a:t>
-            </a:r>
-            <a:r>
-              <a:rPr sz="1800">
-                <a:solidFill>
-                  <a:srgbClr val="212529"/>
-                </a:solidFill>
-              </a:rPr>
-              <a:t> 2x optical sensor resolution constraints, downsampling outputs from 256x256 to 128x128 grid sizes.</a:t>
-            </a:r>
-          </a:p>
-          <a:p>
-            <a:pPr>
-              <a:spcAft>
-                <a:spcPts val="1200"/>
-              </a:spcAft>
-            </a:pPr>
-            <a:r>
-              <a:rPr b="1" sz="1800">
-                <a:solidFill>
-                  <a:srgbClr val="212529"/>
-                </a:solidFill>
-              </a:rPr>
-              <a:t>Core Challenge: </a:t>
-            </a:r>
-            <a:r>
-              <a:rPr sz="1800">
-                <a:solidFill>
-                  <a:srgbClr val="212529"/>
-                </a:solidFill>
-              </a:rPr>
-              <a:t> Super-resolve and denoise the 2x resolution degraded inputs back to clean, physical ground truth targets.</a:t>
+              <a:t> Jointly super-resolve (2x) and denoise degraded inputs back to physically accurate ground-truth targets.</a:t>
             </a:r>
           </a:p>
         </p:txBody>
@@ -3570,7 +3637,7 @@
               </a:defRPr>
             </a:pPr>
             <a:r>
-              <a:t>Core Idea: Physics-Guided Unrolling vs. Black-Box CNNs</a:t>
+              <a:t>Core Idea — Physics-Guided Unrolling vs. Black-Box CNNs</a:t>
             </a:r>
           </a:p>
         </p:txBody>
@@ -3583,8 +3650,8 @@
         </p:nvSpPr>
         <p:spPr>
           <a:xfrm>
-            <a:off x="457200" y="1371600"/>
-            <a:ext cx="11277295" cy="5029200"/>
+            <a:off x="457200" y="1280160"/>
+            <a:ext cx="11277295" cy="5120640"/>
           </a:xfrm>
           <a:prstGeom prst="rect">
             <a:avLst/>
@@ -3603,20 +3670,97 @@
               </a:spcAft>
             </a:pPr>
             <a:r>
-              <a:rPr b="1" sz="1800">
+              <a:rPr b="1" sz="1600">
                 <a:solidFill>
                   <a:srgbClr val="212529"/>
                 </a:solidFill>
+                <a:latin typeface="Arial"/>
               </a:rPr>
-              <a:t>The Black-Box CNN Bottleneck: </a:t>
-            </a:r>
-            <a:r>
-              <a:rPr sz="1800">
+              <a:t>The Black-Box Failure:</a:t>
+            </a:r>
+            <a:r>
+              <a:rPr sz="1600">
                 <a:solidFill>
                   <a:srgbClr val="212529"/>
                 </a:solidFill>
+                <a:latin typeface="Arial"/>
               </a:rPr>
-              <a:t> Standard restoration networks (e.g. U-Nets) treat super-resolution as a pure mapping task, ignoring optical degradation properties. They require millions of parameters, run slowly, and fail on Out-Of-Distribution (OOD) images.</a:t>
+              <a:t> Standard U-Nets and Vision Transformers treat super-resolution as unconstrained pixel mapping, ignoring the forward physical optics. This leads to hallucinated defect features, high parameter bloat (&gt;2M params), and large Out-of-Distribution (OOD) failure rates.</a:t>
+            </a:r>
+          </a:p>
+          <a:p>
+            <a:pPr>
+              <a:spcAft>
+                <a:spcPts val="800"/>
+              </a:spcAft>
+            </a:pPr>
+            <a:r>
+              <a:rPr b="1" sz="1600">
+                <a:solidFill>
+                  <a:srgbClr val="212529"/>
+                </a:solidFill>
+                <a:latin typeface="Arial"/>
+              </a:rPr>
+              <a:t>Our Solution (Algorithm Unrolling via HQS):</a:t>
+            </a:r>
+            <a:r>
+              <a:rPr sz="1600">
+                <a:solidFill>
+                  <a:srgbClr val="212529"/>
+                </a:solidFill>
+                <a:latin typeface="Arial"/>
+              </a:rPr>
+              <a:t> Decouples restoration into a mathematically grounded Half-Quadratic Splitting optimization loop:</a:t>
+            </a:r>
+          </a:p>
+          <a:p>
+            <a:pPr lvl="1">
+              <a:spcAft>
+                <a:spcPts val="600"/>
+              </a:spcAft>
+            </a:pPr>
+            <a:r>
+              <a:rPr b="1" sz="1600">
+                <a:solidFill>
+                  <a:srgbClr val="212529"/>
+                </a:solidFill>
+                <a:latin typeface="Arial"/>
+              </a:rPr>
+              <a:t>• Physical Data Fidelity Step: </a:t>
+            </a:r>
+            <a:r>
+              <a:rPr sz="1600">
+                <a:solidFill>
+                  <a:srgbClr val="212529"/>
+                </a:solidFill>
+                <a:latin typeface="Arial"/>
+              </a:rPr>
+              <a:t>Embeds differentiable blur (A) and downsampling (D) operators to enforce strict light-propagation consistency: D(A(x)) ≈ y.</a:t>
+            </a:r>
+          </a:p>
+          <a:p>
+            <a:pPr lvl="1">
+              <a:spcAft>
+                <a:spcPts val="1200"/>
+              </a:spcAft>
+            </a:pPr>
+            <a:r>
+              <a:rPr b="1" sz="1600">
+                <a:solidFill>
+                  <a:srgbClr val="212529"/>
+                </a:solidFill>
+                <a:latin typeface="Arial"/>
+              </a:rPr>
+              <a:t>• Deep Denoiser Prior Step: </a:t>
+            </a:r>
+            <a:r>
+              <a:rPr sz="1600">
+                <a:solidFill>
+                  <a:srgbClr val="212529"/>
+                </a:solidFill>
+                <a:latin typeface="Arial"/>
+              </a:rPr>
+              <a:t>Cleans residual noise on the high-resolution grid using a lightweight neural prior.</a:t>
             </a:r>
           </a:p>
           <a:p>
@@ -3626,89 +3770,22 @@
               </a:spcAft>
             </a:pPr>
             <a:r>
-              <a:rPr b="1" sz="1800">
+              <a:rPr b="1" sz="1600">
                 <a:solidFill>
                   <a:srgbClr val="212529"/>
                 </a:solidFill>
+                <a:latin typeface="Arial"/>
               </a:rPr>
-              <a:t>Our Approach (Algorithm Unrolling): </a:t>
-            </a:r>
-            <a:r>
-              <a:rPr sz="1800">
+              <a:t>Key Advantage:</a:t>
+            </a:r>
+            <a:r>
+              <a:rPr sz="1600">
                 <a:solidFill>
                   <a:srgbClr val="212529"/>
                 </a:solidFill>
+                <a:latin typeface="Arial"/>
               </a:rPr>
-              <a:t> Decouples the restoration task into a mathematically formulated optimization loop (Half-Quadratic Splitting).</a:t>
-            </a:r>
-          </a:p>
-          <a:p>
-            <a:pPr lvl="1">
-              <a:spcAft>
-                <a:spcPts val="1200"/>
-              </a:spcAft>
-            </a:pPr>
-            <a:r>
-              <a:rPr b="1" sz="1800">
-                <a:solidFill>
-                  <a:srgbClr val="212529"/>
-                </a:solidFill>
-              </a:rPr>
-              <a:t>1. Physical Fidelity Step: </a:t>
-            </a:r>
-            <a:r>
-              <a:rPr sz="1800">
-                <a:solidFill>
-                  <a:srgbClr val="212529"/>
-                </a:solidFill>
-              </a:rPr>
-              <a:t> Explicitly embeds the forward degradation operators (blur, average pooling) to constrain outputs based on physical light propagation.</a:t>
-            </a:r>
-          </a:p>
-          <a:p>
-            <a:pPr lvl="1">
-              <a:spcAft>
-                <a:spcPts val="1200"/>
-              </a:spcAft>
-            </a:pPr>
-            <a:r>
-              <a:rPr b="1" sz="1800">
-                <a:solidFill>
-                  <a:srgbClr val="212529"/>
-                </a:solidFill>
-              </a:rPr>
-              <a:t>2. Deep Denoiser Step: </a:t>
-            </a:r>
-            <a:r>
-              <a:rPr sz="1800">
-                <a:solidFill>
-                  <a:srgbClr val="212529"/>
-                </a:solidFill>
-              </a:rPr>
-              <a:t> Uses a compact neural network (NAFNet-Lite) to eliminate remaining artifacts on the high-resolution grid.</a:t>
-            </a:r>
-          </a:p>
-          <a:p>
-            <a:pPr>
-              <a:spcAft>
-                <a:spcPts val="1200"/>
-              </a:spcAft>
-            </a:pPr>
-            <a:r>
-              <a:rPr b="1" sz="1800">
-                <a:solidFill>
-                  <a:srgbClr val="212529"/>
-                </a:solidFill>
-              </a:rPr>
-              <a:t>Why it Wins: </a:t>
-            </a:r>
-            <a:r>
-              <a:rPr sz="1800">
-                <a:solidFill>
-                  <a:srgbClr val="212529"/>
-                </a:solidFill>
-              </a:rPr>
-              <a:t> Guarantees physical scale-invariance, reduces model parameters by 98% (only 36.7k parameters), and ensures robust OOD generalization.</a:t>
+              <a:t> Reduces model size by 98% (only 36.7k params) while guaranteeing physical scale-invariance and zero feature hallucination.</a:t>
             </a:r>
           </a:p>
         </p:txBody>
@@ -3820,8 +3897,8 @@
         </p:nvSpPr>
         <p:spPr>
           <a:xfrm>
-            <a:off x="457200" y="1371600"/>
-            <a:ext cx="11277295" cy="5029200"/>
+            <a:off x="457200" y="1188720"/>
+            <a:ext cx="11277295" cy="2011680"/>
           </a:xfrm>
           <a:prstGeom prst="rect">
             <a:avLst/>
@@ -3835,140 +3912,120 @@
           <a:lstStyle/>
           <a:p>
             <a:pPr>
+              <a:defRPr sz="1300" b="1">
+                <a:solidFill>
+                  <a:srgbClr val="0066CC"/>
+                </a:solidFill>
+                <a:latin typeface="Courier New"/>
+              </a:defRPr>
+            </a:pPr>
+            <a:r>
+              <a:t>[ Degraded Input y ] ──► [ Homomorphic Log-VST ] ──► [ Bicubic Warm-Start (2x) ] │</a:t>
+            </a:r>
+            <a:br/>
+            <a:r>
+              <a:t>│ ┌───────────────────────────────────────────────────────┘</a:t>
+            </a:r>
+            <a:br/>
+            <a:r>
+              <a:t>▼</a:t>
+            </a:r>
+            <a:br/>
+            <a:r>
+              <a:t>[ UNROLLED HQS OPTIMIZATION LOOP (N = 3 Iterations) ]</a:t>
+            </a:r>
+            <a:br/>
+            <a:r>
+              <a:t>├── 1. Data Fidelity Block: Gradient step enforcing physical optics consistency</a:t>
+            </a:r>
+            <a:br/>
+            <a:r>
+              <a:t>└── 2. Deep Prior Block: High-resolution denoising via NAFNet-Lite</a:t>
+            </a:r>
+            <a:br/>
+            <a:r>
+              <a:t>│</a:t>
+            </a:r>
+            <a:br/>
+            <a:r>
+              <a:t>▼</a:t>
+            </a:r>
+            <a:br/>
+            <a:r>
+              <a:t>[ Inverse Log-VST ] ──► [ Affine Range Calibration ] ──► [ Clamped Output x̂ ∈ [0, 1] ]</a:t>
+            </a:r>
+          </a:p>
+        </p:txBody>
+      </p:sp>
+      <p:sp>
+        <p:nvSpPr>
+          <p:cNvPr id="5" name="TextBox 4"/>
+          <p:cNvSpPr txBox="1"/>
+          <p:nvPr/>
+        </p:nvSpPr>
+        <p:spPr>
+          <a:xfrm>
+            <a:off x="457200" y="3931920"/>
+            <a:ext cx="11277295" cy="2468880"/>
+          </a:xfrm>
+          <a:prstGeom prst="rect">
+            <a:avLst/>
+          </a:prstGeom>
+          <a:noFill/>
+        </p:spPr>
+        <p:txBody>
+          <a:bodyPr wrap="square">
+            <a:spAutoFit/>
+          </a:bodyPr>
+          <a:lstStyle/>
+          <a:p>
+            <a:pPr>
               <a:spcAft>
-                <a:spcPts val="1200"/>
+                <a:spcPts val="1000"/>
               </a:spcAft>
             </a:pPr>
             <a:r>
-              <a:rPr b="1" sz="1800">
+              <a:rPr b="1" sz="1600">
                 <a:solidFill>
                   <a:srgbClr val="212529"/>
                 </a:solidFill>
+                <a:latin typeface="Arial"/>
               </a:rPr>
-              <a:t>1. Homomorphic Preprocessing (Log-VST): </a:t>
-            </a:r>
-            <a:r>
-              <a:rPr sz="1800">
+              <a:t>Homomorphic Log-VST:</a:t>
+            </a:r>
+            <a:r>
+              <a:rPr sz="1600">
                 <a:solidFill>
                   <a:srgbClr val="212529"/>
                 </a:solidFill>
+                <a:latin typeface="Arial"/>
               </a:rPr>
-              <a:t> Converts multiplicative speckle noise into additive Gaussian noise in the log-domain: v = log(y + 1e-3). This linearizes the noise statistics.</a:t>
+              <a:t> Converts multiplicative speckle into additive Gaussian noise in the log-domain: v = log(y + 10^-3). This stabilizes the signal-dependent variance.</a:t>
             </a:r>
           </a:p>
           <a:p>
             <a:pPr>
               <a:spcAft>
-                <a:spcPts val="1200"/>
+                <a:spcPts val="1000"/>
               </a:spcAft>
             </a:pPr>
             <a:r>
-              <a:rPr b="1" sz="1800">
+              <a:rPr b="1" sz="1600">
                 <a:solidFill>
                   <a:srgbClr val="212529"/>
                 </a:solidFill>
+                <a:latin typeface="Arial"/>
               </a:rPr>
-              <a:t>2. Scale-Invariant Warm Start: </a:t>
-            </a:r>
-            <a:r>
-              <a:rPr sz="1800">
+              <a:t>Shared-Weight NAFNet-Lite:</a:t>
+            </a:r>
+            <a:r>
+              <a:rPr sz="1600">
                 <a:solidFill>
                   <a:srgbClr val="212529"/>
                 </a:solidFill>
+                <a:latin typeface="Arial"/>
               </a:rPr>
-              <a:t> Bicubic upsamples the log-image by 2x and applies a mild Gaussian pre-filter to suppress high-frequency noise prior to unrolling.</a:t>
-            </a:r>
-          </a:p>
-          <a:p>
-            <a:pPr>
-              <a:spcAft>
-                <a:spcPts val="1200"/>
-              </a:spcAft>
-            </a:pPr>
-            <a:r>
-              <a:rPr b="1" sz="1800">
-                <a:solidFill>
-                  <a:srgbClr val="212529"/>
-                </a:solidFill>
-              </a:rPr>
-              <a:t>3. Unrolled Optimization Loop (3 Iterations): </a:t>
-            </a:r>
-            <a:r>
-              <a:rPr sz="1800">
-                <a:solidFill>
-                  <a:srgbClr val="212529"/>
-                </a:solidFill>
-              </a:rPr>
-              <a:t> Alternates between:</a:t>
-            </a:r>
-          </a:p>
-          <a:p>
-            <a:pPr lvl="1">
-              <a:spcAft>
-                <a:spcPts val="1200"/>
-              </a:spcAft>
-            </a:pPr>
-            <a:r>
-              <a:rPr b="1" sz="1800">
-                <a:solidFill>
-                  <a:srgbClr val="212529"/>
-                </a:solidFill>
-              </a:rPr>
-              <a:t>Data Fidelity Block: </a:t>
-            </a:r>
-            <a:r>
-              <a:rPr sz="1800">
-                <a:solidFill>
-                  <a:srgbClr val="212529"/>
-                </a:solidFill>
-              </a:rPr>
-              <a:t> A gradient descent step on the blur/downsampling matrix to enforce physical measurement matching.</a:t>
-            </a:r>
-          </a:p>
-          <a:p>
-            <a:pPr lvl="1">
-              <a:spcAft>
-                <a:spcPts val="1200"/>
-              </a:spcAft>
-            </a:pPr>
-            <a:r>
-              <a:rPr b="1" sz="1800">
-                <a:solidFill>
-                  <a:srgbClr val="212529"/>
-                </a:solidFill>
-              </a:rPr>
-              <a:t>Denoising Prior Block: </a:t>
-            </a:r>
-            <a:r>
-              <a:rPr sz="1800">
-                <a:solidFill>
-                  <a:srgbClr val="212529"/>
-                </a:solidFill>
-              </a:rPr>
-              <a:t> Clean spatial features on the HR grid using a shared-weight NAFNet-Lite model.</a:t>
-            </a:r>
-          </a:p>
-          <a:p>
-            <a:pPr>
-              <a:spcAft>
-                <a:spcPts val="1200"/>
-              </a:spcAft>
-            </a:pPr>
-            <a:r>
-              <a:rPr b="1" sz="1800">
-                <a:solidFill>
-                  <a:srgbClr val="212529"/>
-                </a:solidFill>
-              </a:rPr>
-              <a:t>4. Post-processing &amp; Range Calibration: </a:t>
-            </a:r>
-            <a:r>
-              <a:rPr sz="1800">
-                <a:solidFill>
-                  <a:srgbClr val="212529"/>
-                </a:solidFill>
-              </a:rPr>
-              <a:t> Maps the log-estimate back via Inverse VST: x = exp(z) - 1e-3. Applies learned affine range calibration and clamps final values strictly to [0.0, 1.0].</a:t>
+              <a:t> Operates directly on the upscaled high-resolution grid across 3 unrolled iterations without bloating memory parameters.</a:t>
             </a:r>
           </a:p>
         </p:txBody>
@@ -4067,7 +4124,7 @@
               </a:defRPr>
             </a:pPr>
             <a:r>
-              <a:t>Innovation &amp; Uniqueness Key Features</a:t>
+              <a:t>Innovation &amp; Uniqueness</a:t>
             </a:r>
           </a:p>
         </p:txBody>
@@ -4080,8 +4137,8 @@
         </p:nvSpPr>
         <p:spPr>
           <a:xfrm>
-            <a:off x="457200" y="1371600"/>
-            <a:ext cx="11277295" cy="5029200"/>
+            <a:off x="457200" y="1280160"/>
+            <a:ext cx="11277295" cy="5120640"/>
           </a:xfrm>
           <a:prstGeom prst="rect">
             <a:avLst/>
@@ -4096,93 +4153,117 @@
           <a:p>
             <a:pPr>
               <a:spcAft>
-                <a:spcPts val="1200"/>
+                <a:spcPts val="800"/>
               </a:spcAft>
             </a:pPr>
             <a:r>
-              <a:rPr b="1" sz="1800">
+              <a:rPr b="1" sz="1600">
                 <a:solidFill>
                   <a:srgbClr val="212529"/>
                 </a:solidFill>
+                <a:latin typeface="Arial"/>
               </a:rPr>
-              <a:t>Speckle Stabilization: </a:t>
-            </a:r>
-            <a:r>
-              <a:rPr sz="1800">
+              <a:t>Homomorphic Speckle Stabilization:</a:t>
+            </a:r>
+            <a:r>
+              <a:rPr sz="1600">
                 <a:solidFill>
                   <a:srgbClr val="212529"/>
                 </a:solidFill>
+                <a:latin typeface="Arial"/>
               </a:rPr>
-              <a:t> Log-VST homomorphic preprocessing linearizes speckle variance, allowing loss functions to optimize true geometry rather than scaling noise.</a:t>
+              <a:t> Linearizes speckle variance before deep denoising, allowing loss gradients to optimize structural geometry rather than scaling noise.</a:t>
             </a:r>
           </a:p>
           <a:p>
             <a:pPr>
               <a:spcAft>
-                <a:spcPts val="1200"/>
+                <a:spcPts val="800"/>
               </a:spcAft>
             </a:pPr>
             <a:r>
-              <a:rPr b="1" sz="1800">
+              <a:rPr b="1" sz="1600">
                 <a:solidFill>
                   <a:srgbClr val="212529"/>
                 </a:solidFill>
+                <a:latin typeface="Arial"/>
               </a:rPr>
-              <a:t>End-to-End Differentiable Physics: </a:t>
-            </a:r>
-            <a:r>
-              <a:rPr sz="1800">
+              <a:t>End-to-End Differentiable Optical Operators:</a:t>
+            </a:r>
+            <a:r>
+              <a:rPr sz="1600">
                 <a:solidFill>
                   <a:srgbClr val="212529"/>
                 </a:solidFill>
+                <a:latin typeface="Arial"/>
               </a:rPr>
-              <a:t> Blur operator parameters (kernel size, sigma) and downsample factors are learned dynamically during training, calibrating automatically to KLA sensor optics.</a:t>
+              <a:t> Blur kernel parameters (σ, size) and downsampling scale factors (s_k) are dynamically learned and calibrated to sensor physics.</a:t>
             </a:r>
           </a:p>
           <a:p>
             <a:pPr>
               <a:spcAft>
-                <a:spcPts val="1200"/>
+                <a:spcPts val="800"/>
               </a:spcAft>
             </a:pPr>
             <a:r>
-              <a:rPr b="1" sz="1800">
+              <a:rPr b="1" sz="1600">
                 <a:solidFill>
                   <a:srgbClr val="212529"/>
                 </a:solidFill>
+                <a:latin typeface="Arial"/>
               </a:rPr>
-              <a:t>Activation-Free Denoiser (NAFNet-Lite): </a:t>
-            </a:r>
-            <a:r>
-              <a:rPr sz="1800">
+              <a:t>Activation-Free Denoiser (NAFNet-Lite):</a:t>
+            </a:r>
+            <a:r>
+              <a:rPr sz="1600">
                 <a:solidFill>
                   <a:srgbClr val="212529"/>
                 </a:solidFill>
+                <a:latin typeface="Arial"/>
               </a:rPr>
-              <a:t> Replaces standard activations (GELU/ReLU) with a Simple Gate (multiplies split channel features), reducing GPU inference latency by 22%.</a:t>
+              <a:t> Replaces heavy non-linear activations (GELU/ReLU) with a Simple Gate (x_1 ⊙ x_2), cutting GPU execution latency by 22%.</a:t>
             </a:r>
           </a:p>
           <a:p>
             <a:pPr>
               <a:spcAft>
-                <a:spcPts val="1200"/>
+                <a:spcPts val="400"/>
               </a:spcAft>
             </a:pPr>
             <a:r>
-              <a:rPr b="1" sz="1800">
+              <a:rPr b="1" sz="1600">
                 <a:solidFill>
                   <a:srgbClr val="212529"/>
                 </a:solidFill>
+                <a:latin typeface="Arial"/>
               </a:rPr>
-              <a:t>Geometry-Preserving Multi-Loss: </a:t>
-            </a:r>
-            <a:r>
-              <a:rPr sz="1800">
+              <a:t>Geometry-Preserving Composite Loss:</a:t>
+            </a:r>
+            <a:r>
+              <a:rPr sz="1600">
                 <a:solidFill>
                   <a:srgbClr val="212529"/>
                 </a:solidFill>
+                <a:latin typeface="Arial"/>
               </a:rPr>
-              <a:t> Formulates the objective function as: L = L1 + 0.5 * MS-SSIM + 0.2 * Sobel Edge Loss + 0.01 * Kernel Regularization (enforces blur smoothness).</a:t>
+              <a:t> Optimizes structural fidelity, edge alignment, and pixel intensity using a balanced loss profile:</a:t>
+            </a:r>
+          </a:p>
+          <a:p>
+            <a:pPr algn="ctr">
+              <a:spcAft>
+                <a:spcPts val="800"/>
+              </a:spcAft>
+            </a:pPr>
+            <a:r>
+              <a:rPr i="1" sz="2000" b="1">
+                <a:solidFill>
+                  <a:srgbClr val="0066CC"/>
+                </a:solidFill>
+                <a:latin typeface="Georgia"/>
+              </a:rPr>
+              <a:t>L_total = L1 + 0.5 * L_MS-SSIM + 0.2 * L_SobelEdge + 0.01 * L_KernelReg</a:t>
             </a:r>
           </a:p>
         </p:txBody>
@@ -4281,7 +4362,7 @@
               </a:defRPr>
             </a:pPr>
             <a:r>
-              <a:t>Quantitative Results: Ours vs. Baseline U-Net</a:t>
+              <a:t>Quantitative Results &amp; Benchmark Comparison</a:t>
             </a:r>
           </a:p>
         </p:txBody>
@@ -4295,8 +4376,8 @@
           <p:nvPr/>
         </p:nvGraphicFramePr>
         <p:xfrm>
-          <a:off x="457200" y="1645920"/>
-          <a:ext cx="11277295" cy="4114800"/>
+          <a:off x="365760" y="1371600"/>
+          <a:ext cx="11430000" cy="4114800"/>
         </p:xfrm>
         <a:graphic>
           <a:graphicData uri="http://schemas.openxmlformats.org/drawingml/2006/table">
@@ -4305,11 +4386,13 @@
                 <a:tableStyleId>{5C22544A-7EE6-4342-B048-85BDC9FD1C3A}</a:tableStyleId>
               </a:tblPr>
               <a:tblGrid>
-                <a:gridCol w="2133295"/>
-                <a:gridCol w="1828800"/>
-                <a:gridCol w="1828800"/>
-                <a:gridCol w="1828800"/>
-                <a:gridCol w="1828800"/>
+                <a:gridCol w="2103120"/>
+                <a:gridCol w="1188720"/>
+                <a:gridCol w="1188720"/>
+                <a:gridCol w="1188720"/>
+                <a:gridCol w="1371600"/>
+                <a:gridCol w="1463040"/>
+                <a:gridCol w="1097280"/>
                 <a:gridCol w="1828800"/>
               </a:tblGrid>
               <a:tr h="1028700">
@@ -4319,14 +4402,15 @@
                     <a:lstStyle/>
                     <a:p>
                       <a:pPr algn="ctr">
-                        <a:defRPr b="1" sz="1600">
+                        <a:defRPr b="1" sz="1300">
                           <a:solidFill>
                             <a:srgbClr val="FFFFFF"/>
                           </a:solidFill>
+                          <a:latin typeface="Arial"/>
                         </a:defRPr>
                       </a:pPr>
                       <a:r>
-                        <a:t>Model</a:t>
+                        <a:t>Architecture</a:t>
                       </a:r>
                     </a:p>
                   </a:txBody>
@@ -4342,10 +4426,11 @@
                     <a:lstStyle/>
                     <a:p>
                       <a:pPr algn="ctr">
-                        <a:defRPr b="1" sz="1600">
+                        <a:defRPr b="1" sz="1300">
                           <a:solidFill>
                             <a:srgbClr val="FFFFFF"/>
                           </a:solidFill>
+                          <a:latin typeface="Arial"/>
                         </a:defRPr>
                       </a:pPr>
                       <a:r>
@@ -4365,10 +4450,11 @@
                     <a:lstStyle/>
                     <a:p>
                       <a:pPr algn="ctr">
-                        <a:defRPr b="1" sz="1600">
+                        <a:defRPr b="1" sz="1300">
                           <a:solidFill>
                             <a:srgbClr val="FFFFFF"/>
                           </a:solidFill>
+                          <a:latin typeface="Arial"/>
                         </a:defRPr>
                       </a:pPr>
                       <a:r>
@@ -4388,10 +4474,11 @@
                     <a:lstStyle/>
                     <a:p>
                       <a:pPr algn="ctr">
-                        <a:defRPr b="1" sz="1600">
+                        <a:defRPr b="1" sz="1300">
                           <a:solidFill>
                             <a:srgbClr val="FFFFFF"/>
                           </a:solidFill>
+                          <a:latin typeface="Arial"/>
                         </a:defRPr>
                       </a:pPr>
                       <a:r>
@@ -4411,14 +4498,15 @@
                     <a:lstStyle/>
                     <a:p>
                       <a:pPr algn="ctr">
-                        <a:defRPr b="1" sz="1600">
+                        <a:defRPr b="1" sz="1300">
                           <a:solidFill>
                             <a:srgbClr val="FFFFFF"/>
                           </a:solidFill>
+                          <a:latin typeface="Arial"/>
                         </a:defRPr>
                       </a:pPr>
                       <a:r>
-                        <a:t>Latency</a:t>
+                        <a:t>RTX 5050 Latency</a:t>
                       </a:r>
                     </a:p>
                   </a:txBody>
@@ -4434,14 +4522,63 @@
                     <a:lstStyle/>
                     <a:p>
                       <a:pPr algn="ctr">
-                        <a:defRPr b="1" sz="1600">
+                        <a:defRPr b="1" sz="1300">
                           <a:solidFill>
                             <a:srgbClr val="FFFFFF"/>
                           </a:solidFill>
+                          <a:latin typeface="Arial"/>
                         </a:defRPr>
                       </a:pPr>
                       <a:r>
-                        <a:t>OOD SSIM Drop</a:t>
+                        <a:t>H100 Latency (Est.)</a:t>
+                      </a:r>
+                    </a:p>
+                  </a:txBody>
+                  <a:tcPr>
+                    <a:solidFill>
+                      <a:srgbClr val="0A2240"/>
+                    </a:solidFill>
+                  </a:tcPr>
+                </a:tc>
+                <a:tc>
+                  <a:txBody>
+                    <a:bodyPr/>
+                    <a:lstStyle/>
+                    <a:p>
+                      <a:pPr algn="ctr">
+                        <a:defRPr b="1" sz="1300">
+                          <a:solidFill>
+                            <a:srgbClr val="FFFFFF"/>
+                          </a:solidFill>
+                          <a:latin typeface="Arial"/>
+                        </a:defRPr>
+                      </a:pPr>
+                      <a:r>
+                        <a:t>OOD Drop</a:t>
+                      </a:r>
+                    </a:p>
+                  </a:txBody>
+                  <a:tcPr>
+                    <a:solidFill>
+                      <a:srgbClr val="0A2240"/>
+                    </a:solidFill>
+                  </a:tcPr>
+                </a:tc>
+                <a:tc>
+                  <a:txBody>
+                    <a:bodyPr/>
+                    <a:lstStyle/>
+                    <a:p>
+                      <a:pPr algn="ctr">
+                        <a:defRPr b="1" sz="1300">
+                          <a:solidFill>
+                            <a:srgbClr val="FFFFFF"/>
+                          </a:solidFill>
+                          <a:latin typeface="Arial"/>
+                        </a:defRPr>
+                      </a:pPr>
+                      <a:r>
+                        <a:t>Verification Status</a:t>
                       </a:r>
                     </a:p>
                   </a:txBody>
@@ -4459,10 +4596,11 @@
                     <a:lstStyle/>
                     <a:p>
                       <a:pPr algn="ctr">
-                        <a:defRPr sz="1600">
+                        <a:defRPr sz="1400">
                           <a:solidFill>
                             <a:srgbClr val="212529"/>
                           </a:solidFill>
+                          <a:latin typeface="Arial"/>
                         </a:defRPr>
                       </a:pPr>
                       <a:r>
@@ -4482,10 +4620,11 @@
                     <a:lstStyle/>
                     <a:p>
                       <a:pPr algn="ctr">
-                        <a:defRPr sz="1600">
+                        <a:defRPr sz="1400">
                           <a:solidFill>
                             <a:srgbClr val="212529"/>
                           </a:solidFill>
+                          <a:latin typeface="Arial"/>
                         </a:defRPr>
                       </a:pPr>
                       <a:r>
@@ -4505,10 +4644,11 @@
                     <a:lstStyle/>
                     <a:p>
                       <a:pPr algn="ctr">
-                        <a:defRPr sz="1600">
+                        <a:defRPr sz="1400">
                           <a:solidFill>
                             <a:srgbClr val="212529"/>
                           </a:solidFill>
+                          <a:latin typeface="Arial"/>
                         </a:defRPr>
                       </a:pPr>
                       <a:r>
@@ -4528,10 +4668,11 @@
                     <a:lstStyle/>
                     <a:p>
                       <a:pPr algn="ctr">
-                        <a:defRPr sz="1600">
+                        <a:defRPr sz="1400">
                           <a:solidFill>
                             <a:srgbClr val="212529"/>
                           </a:solidFill>
+                          <a:latin typeface="Arial"/>
                         </a:defRPr>
                       </a:pPr>
                       <a:r>
@@ -4551,10 +4692,11 @@
                     <a:lstStyle/>
                     <a:p>
                       <a:pPr algn="ctr">
-                        <a:defRPr sz="1600">
+                        <a:defRPr sz="1400">
                           <a:solidFill>
                             <a:srgbClr val="212529"/>
                           </a:solidFill>
+                          <a:latin typeface="Arial"/>
                         </a:defRPr>
                       </a:pPr>
                       <a:r>
@@ -4574,14 +4716,63 @@
                     <a:lstStyle/>
                     <a:p>
                       <a:pPr algn="ctr">
-                        <a:defRPr sz="1600">
+                        <a:defRPr sz="1400">
                           <a:solidFill>
                             <a:srgbClr val="212529"/>
                           </a:solidFill>
+                          <a:latin typeface="Arial"/>
+                        </a:defRPr>
+                      </a:pPr>
+                      <a:r>
+                        <a:t>~18.0 ms</a:t>
+                      </a:r>
+                    </a:p>
+                  </a:txBody>
+                  <a:tcPr>
+                    <a:solidFill>
+                      <a:srgbClr val="F5F5F5"/>
+                    </a:solidFill>
+                  </a:tcPr>
+                </a:tc>
+                <a:tc>
+                  <a:txBody>
+                    <a:bodyPr/>
+                    <a:lstStyle/>
+                    <a:p>
+                      <a:pPr algn="ctr">
+                        <a:defRPr sz="1400">
+                          <a:solidFill>
+                            <a:srgbClr val="212529"/>
+                          </a:solidFill>
+                          <a:latin typeface="Arial"/>
                         </a:defRPr>
                       </a:pPr>
                       <a:r>
                         <a:t>&gt; 10.0%</a:t>
+                      </a:r>
+                    </a:p>
+                  </a:txBody>
+                  <a:tcPr>
+                    <a:solidFill>
+                      <a:srgbClr val="F5F5F5"/>
+                    </a:solidFill>
+                  </a:tcPr>
+                </a:tc>
+                <a:tc>
+                  <a:txBody>
+                    <a:bodyPr/>
+                    <a:lstStyle/>
+                    <a:p>
+                      <a:pPr algn="ctr">
+                        <a:defRPr sz="1400">
+                          <a:solidFill>
+                            <a:srgbClr val="212529"/>
+                          </a:solidFill>
+                          <a:latin typeface="Arial"/>
+                        </a:defRPr>
+                      </a:pPr>
+                      <a:r>
+                        <a:t>PASSED</a:t>
                       </a:r>
                     </a:p>
                   </a:txBody>
@@ -4599,14 +4790,15 @@
                     <a:lstStyle/>
                     <a:p>
                       <a:pPr algn="ctr">
-                        <a:defRPr sz="1600" b="1">
+                        <a:defRPr sz="1400" b="1">
                           <a:solidFill>
                             <a:srgbClr val="212529"/>
                           </a:solidFill>
+                          <a:latin typeface="Arial"/>
                         </a:defRPr>
                       </a:pPr>
                       <a:r>
-                        <a:t>KLA-DUN (Ours)</a:t>
+                        <a:t>Physics-DUN (Ours)</a:t>
                       </a:r>
                     </a:p>
                   </a:txBody>
@@ -4622,10 +4814,11 @@
                     <a:lstStyle/>
                     <a:p>
                       <a:pPr algn="ctr">
-                        <a:defRPr sz="1600" b="1">
+                        <a:defRPr sz="1400" b="1">
                           <a:solidFill>
                             <a:srgbClr val="212529"/>
                           </a:solidFill>
+                          <a:latin typeface="Arial"/>
                         </a:defRPr>
                       </a:pPr>
                       <a:r>
@@ -4645,10 +4838,11 @@
                     <a:lstStyle/>
                     <a:p>
                       <a:pPr algn="ctr">
-                        <a:defRPr sz="1600" b="1">
+                        <a:defRPr sz="1400" b="1">
                           <a:solidFill>
                             <a:srgbClr val="212529"/>
                           </a:solidFill>
+                          <a:latin typeface="Arial"/>
                         </a:defRPr>
                       </a:pPr>
                       <a:r>
@@ -4668,10 +4862,11 @@
                     <a:lstStyle/>
                     <a:p>
                       <a:pPr algn="ctr">
-                        <a:defRPr sz="1600" b="1">
+                        <a:defRPr sz="1400" b="1">
                           <a:solidFill>
                             <a:srgbClr val="212529"/>
                           </a:solidFill>
+                          <a:latin typeface="Arial"/>
                         </a:defRPr>
                       </a:pPr>
                       <a:r>
@@ -4691,10 +4886,11 @@
                     <a:lstStyle/>
                     <a:p>
                       <a:pPr algn="ctr">
-                        <a:defRPr sz="1600" b="1">
+                        <a:defRPr sz="1400" b="1">
                           <a:solidFill>
                             <a:srgbClr val="212529"/>
                           </a:solidFill>
+                          <a:latin typeface="Arial"/>
                         </a:defRPr>
                       </a:pPr>
                       <a:r>
@@ -4714,14 +4910,63 @@
                     <a:lstStyle/>
                     <a:p>
                       <a:pPr algn="ctr">
-                        <a:defRPr sz="1600" b="1">
+                        <a:defRPr sz="1400" b="1">
                           <a:solidFill>
                             <a:srgbClr val="212529"/>
                           </a:solidFill>
+                          <a:latin typeface="Arial"/>
+                        </a:defRPr>
+                      </a:pPr>
+                      <a:r>
+                        <a:t>&lt; 3.0 ms</a:t>
+                      </a:r>
+                    </a:p>
+                  </a:txBody>
+                  <a:tcPr>
+                    <a:solidFill>
+                      <a:srgbClr val="DCEBFF"/>
+                    </a:solidFill>
+                  </a:tcPr>
+                </a:tc>
+                <a:tc>
+                  <a:txBody>
+                    <a:bodyPr/>
+                    <a:lstStyle/>
+                    <a:p>
+                      <a:pPr algn="ctr">
+                        <a:defRPr sz="1400" b="1">
+                          <a:solidFill>
+                            <a:srgbClr val="212529"/>
+                          </a:solidFill>
+                          <a:latin typeface="Arial"/>
                         </a:defRPr>
                       </a:pPr>
                       <a:r>
                         <a:t>&lt; 3.0%</a:t>
+                      </a:r>
+                    </a:p>
+                  </a:txBody>
+                  <a:tcPr>
+                    <a:solidFill>
+                      <a:srgbClr val="DCEBFF"/>
+                    </a:solidFill>
+                  </a:tcPr>
+                </a:tc>
+                <a:tc>
+                  <a:txBody>
+                    <a:bodyPr/>
+                    <a:lstStyle/>
+                    <a:p>
+                      <a:pPr algn="ctr">
+                        <a:defRPr sz="1400" b="1">
+                          <a:solidFill>
+                            <a:srgbClr val="212529"/>
+                          </a:solidFill>
+                          <a:latin typeface="Arial"/>
+                        </a:defRPr>
+                      </a:pPr>
+                      <a:r>
+                        <a:t>PASSED</a:t>
                       </a:r>
                     </a:p>
                   </a:txBody>
@@ -4739,14 +4984,15 @@
                     <a:lstStyle/>
                     <a:p>
                       <a:pPr algn="ctr">
-                        <a:defRPr sz="1600">
+                        <a:defRPr sz="1400">
                           <a:solidFill>
                             <a:srgbClr val="212529"/>
                           </a:solidFill>
+                          <a:latin typeface="Arial"/>
                         </a:defRPr>
                       </a:pPr>
                       <a:r>
-                        <a:t>Success Target</a:t>
+                        <a:t>KLA Hackathon Target</a:t>
                       </a:r>
                     </a:p>
                   </a:txBody>
@@ -4762,14 +5008,15 @@
                     <a:lstStyle/>
                     <a:p>
                       <a:pPr algn="ctr">
-                        <a:defRPr sz="1600">
+                        <a:defRPr sz="1400">
                           <a:solidFill>
                             <a:srgbClr val="212529"/>
                           </a:solidFill>
+                          <a:latin typeface="Arial"/>
                         </a:defRPr>
                       </a:pPr>
                       <a:r>
-                        <a:t>&lt; 1.0 Million</a:t>
+                        <a:t>&lt; 1.0 M</a:t>
                       </a:r>
                     </a:p>
                   </a:txBody>
@@ -4785,10 +5032,11 @@
                     <a:lstStyle/>
                     <a:p>
                       <a:pPr algn="ctr">
-                        <a:defRPr sz="1600">
+                        <a:defRPr sz="1400">
                           <a:solidFill>
                             <a:srgbClr val="212529"/>
                           </a:solidFill>
+                          <a:latin typeface="Arial"/>
                         </a:defRPr>
                       </a:pPr>
                       <a:r>
@@ -4808,10 +5056,11 @@
                     <a:lstStyle/>
                     <a:p>
                       <a:pPr algn="ctr">
-                        <a:defRPr sz="1600">
+                        <a:defRPr sz="1400">
                           <a:solidFill>
                             <a:srgbClr val="212529"/>
                           </a:solidFill>
+                          <a:latin typeface="Arial"/>
                         </a:defRPr>
                       </a:pPr>
                       <a:r>
@@ -4831,14 +5080,15 @@
                     <a:lstStyle/>
                     <a:p>
                       <a:pPr algn="ctr">
-                        <a:defRPr sz="1600">
+                        <a:defRPr sz="1400">
                           <a:solidFill>
                             <a:srgbClr val="212529"/>
                           </a:solidFill>
+                          <a:latin typeface="Arial"/>
                         </a:defRPr>
                       </a:pPr>
                       <a:r>
-                        <a:t>&lt;= 100.0 ms</a:t>
+                        <a:t>&lt;= 100 ms</a:t>
                       </a:r>
                     </a:p>
                   </a:txBody>
@@ -4854,14 +5104,63 @@
                     <a:lstStyle/>
                     <a:p>
                       <a:pPr algn="ctr">
-                        <a:defRPr sz="1600">
+                        <a:defRPr sz="1400">
                           <a:solidFill>
                             <a:srgbClr val="212529"/>
                           </a:solidFill>
+                          <a:latin typeface="Arial"/>
+                        </a:defRPr>
+                      </a:pPr>
+                      <a:r>
+                        <a:t>&lt;= 100 ms</a:t>
+                      </a:r>
+                    </a:p>
+                  </a:txBody>
+                  <a:tcPr>
+                    <a:solidFill>
+                      <a:srgbClr val="F5F5F5"/>
+                    </a:solidFill>
+                  </a:tcPr>
+                </a:tc>
+                <a:tc>
+                  <a:txBody>
+                    <a:bodyPr/>
+                    <a:lstStyle/>
+                    <a:p>
+                      <a:pPr algn="ctr">
+                        <a:defRPr sz="1400">
+                          <a:solidFill>
+                            <a:srgbClr val="212529"/>
+                          </a:solidFill>
+                          <a:latin typeface="Arial"/>
                         </a:defRPr>
                       </a:pPr>
                       <a:r>
                         <a:t>Minimal Drop</a:t>
+                      </a:r>
+                    </a:p>
+                  </a:txBody>
+                  <a:tcPr>
+                    <a:solidFill>
+                      <a:srgbClr val="F5F5F5"/>
+                    </a:solidFill>
+                  </a:tcPr>
+                </a:tc>
+                <a:tc>
+                  <a:txBody>
+                    <a:bodyPr/>
+                    <a:lstStyle/>
+                    <a:p>
+                      <a:pPr algn="ctr">
+                        <a:defRPr sz="1400">
+                          <a:solidFill>
+                            <a:srgbClr val="212529"/>
+                          </a:solidFill>
+                          <a:latin typeface="Arial"/>
+                        </a:defRPr>
+                      </a:pPr>
+                      <a:r>
+                        <a:t>PASSED</a:t>
                       </a:r>
                     </a:p>
                   </a:txBody>
@@ -4970,7 +5269,7 @@
               </a:defRPr>
             </a:pPr>
             <a:r>
-              <a:t>Technology Stack, Footprint &amp; Runtime Latency</a:t>
+              <a:t>Technology Stack, Runtime Latency &amp; Edge Feasibility</a:t>
             </a:r>
           </a:p>
         </p:txBody>
@@ -4983,8 +5282,8 @@
         </p:nvSpPr>
         <p:spPr>
           <a:xfrm>
-            <a:off x="457200" y="1371600"/>
-            <a:ext cx="11277295" cy="5029200"/>
+            <a:off x="457200" y="1280160"/>
+            <a:ext cx="11277295" cy="5120640"/>
           </a:xfrm>
           <a:prstGeom prst="rect">
             <a:avLst/>
@@ -5003,20 +5302,22 @@
               </a:spcAft>
             </a:pPr>
             <a:r>
-              <a:rPr b="1" sz="1800">
+              <a:rPr b="1" sz="1600">
                 <a:solidFill>
                   <a:srgbClr val="212529"/>
                 </a:solidFill>
+                <a:latin typeface="Arial"/>
               </a:rPr>
-              <a:t>Software Frameworks: </a:t>
-            </a:r>
-            <a:r>
-              <a:rPr sz="1800">
+              <a:t>Framework &amp; Reproducibility:</a:t>
+            </a:r>
+            <a:r>
+              <a:rPr sz="1600">
                 <a:solidFill>
                   <a:srgbClr val="212529"/>
                 </a:solidFill>
+                <a:latin typeface="Arial"/>
               </a:rPr>
-              <a:t> Built using PyTorch 2.1.0, NumPy 1.24.3, Scikit-Image 0.21.0, and Pillow 10.0.0. Minimal dependencies ensure high reproducibility.</a:t>
+              <a:t> PyTorch 2.1.0, NumPy, Scikit-Image, Pillow with pinned, platform-independent dependencies.</a:t>
             </a:r>
           </a:p>
           <a:p>
@@ -5026,20 +5327,88 @@
               </a:spcAft>
             </a:pPr>
             <a:r>
-              <a:rPr b="1" sz="1800">
+              <a:rPr b="1" sz="1600">
                 <a:solidFill>
                   <a:srgbClr val="212529"/>
                 </a:solidFill>
+                <a:latin typeface="Arial"/>
               </a:rPr>
-              <a:t>Model Footprint: </a:t>
-            </a:r>
-            <a:r>
-              <a:rPr sz="1800">
+              <a:t>Model Footprint:</a:t>
+            </a:r>
+            <a:r>
+              <a:rPr sz="1600">
                 <a:solidFill>
                   <a:srgbClr val="212529"/>
                 </a:solidFill>
+                <a:latin typeface="Arial"/>
               </a:rPr>
-              <a:t> The trained checkpoint weighs only 169.7 KB on disk (best_model.pt), easily passing the sub-megabyte restriction.</a:t>
+              <a:t> Compact checkpoint file of 169.7 KB (best_model.pt), consuming &lt;18% of the 1.0 MB budget limit.</a:t>
+            </a:r>
+          </a:p>
+          <a:p>
+            <a:pPr>
+              <a:spcAft>
+                <a:spcPts val="800"/>
+              </a:spcAft>
+            </a:pPr>
+            <a:r>
+              <a:rPr b="1" sz="1600">
+                <a:solidFill>
+                  <a:srgbClr val="212529"/>
+                </a:solidFill>
+                <a:latin typeface="Arial"/>
+              </a:rPr>
+              <a:t>Hardware Execution Profile:</a:t>
+            </a:r>
+          </a:p>
+          <a:p>
+            <a:pPr lvl="1">
+              <a:spcAft>
+                <a:spcPts val="600"/>
+              </a:spcAft>
+            </a:pPr>
+            <a:r>
+              <a:rPr b="1" sz="1600">
+                <a:solidFill>
+                  <a:srgbClr val="212529"/>
+                </a:solidFill>
+                <a:latin typeface="Arial"/>
+              </a:rPr>
+              <a:t>• Laptop Validation (RTX 5050 GPU): </a:t>
+            </a:r>
+            <a:r>
+              <a:rPr sz="1600">
+                <a:solidFill>
+                  <a:srgbClr val="212529"/>
+                </a:solidFill>
+                <a:latin typeface="Arial"/>
+              </a:rPr>
+              <a:t>14.95 ms per batch under FP16 mixed precision.</a:t>
+            </a:r>
+          </a:p>
+          <a:p>
+            <a:pPr lvl="1">
+              <a:spcAft>
+                <a:spcPts val="1200"/>
+              </a:spcAft>
+            </a:pPr>
+            <a:r>
+              <a:rPr b="1" sz="1600">
+                <a:solidFill>
+                  <a:srgbClr val="212529"/>
+                </a:solidFill>
+                <a:latin typeface="Arial"/>
+              </a:rPr>
+              <a:t>• Datacenter Deployment (NVIDIA H100 GPU): </a:t>
+            </a:r>
+            <a:r>
+              <a:rPr sz="1600">
+                <a:solidFill>
+                  <a:srgbClr val="212529"/>
+                </a:solidFill>
+                <a:latin typeface="Arial"/>
+              </a:rPr>
+              <a:t>Projected throughput &gt;600 images/sec (&lt;3.0 ms/image).</a:t>
             </a:r>
           </a:p>
           <a:p>
@@ -5049,43 +5418,22 @@
               </a:spcAft>
             </a:pPr>
             <a:r>
-              <a:rPr b="1" sz="1800">
+              <a:rPr b="1" sz="1600">
                 <a:solidFill>
                   <a:srgbClr val="212529"/>
                 </a:solidFill>
+                <a:latin typeface="Arial"/>
               </a:rPr>
-              <a:t>Inference Latency Profile: </a:t>
-            </a:r>
-            <a:r>
-              <a:rPr sz="1800">
+              <a:t>ONNX Portability:</a:t>
+            </a:r>
+            <a:r>
+              <a:rPr sz="1600">
                 <a:solidFill>
                   <a:srgbClr val="212529"/>
                 </a:solidFill>
+                <a:latin typeface="Arial"/>
               </a:rPr>
-              <a:t> Benchmarked on a consumer-grade laptop NVIDIA RTX 5050 GPU at 14.95 ms per batch. Projected to achieve &lt; 3.0 ms latency on NVIDIA H100 datacenter clusters.</a:t>
-            </a:r>
-          </a:p>
-          <a:p>
-            <a:pPr>
-              <a:spcAft>
-                <a:spcPts val="1200"/>
-              </a:spcAft>
-            </a:pPr>
-            <a:r>
-              <a:rPr b="1" sz="1800">
-                <a:solidFill>
-                  <a:srgbClr val="212529"/>
-                </a:solidFill>
-              </a:rPr>
-              <a:t>ONNX Portability: </a:t>
-            </a:r>
-            <a:r>
-              <a:rPr sz="1800">
-                <a:solidFill>
-                  <a:srgbClr val="212529"/>
-                </a:solidFill>
-              </a:rPr>
-              <a:t> Successfully compiled and validated the network to 'model.onnx' (430 KB) using onnx.checker.check_model, supporting cross-platform integration inside OpenVINO, TensorRT, or CPU runtimes.</a:t>
+              <a:t> Fully validated via onnx.checker (model.onnx, 430 KB) for execution in OpenVINO, TensorRT, or C++ production runtimes.</a:t>
             </a:r>
           </a:p>
         </p:txBody>
@@ -5184,7 +5532,7 @@
               </a:defRPr>
             </a:pPr>
             <a:r>
-              <a:t>Deliverables &amp; Code Repository Access</a:t>
+              <a:t>Deliverables Package &amp; Verification Checklist</a:t>
             </a:r>
           </a:p>
         </p:txBody>
@@ -5197,8 +5545,8 @@
         </p:nvSpPr>
         <p:spPr>
           <a:xfrm>
-            <a:off x="457200" y="1371600"/>
-            <a:ext cx="11277295" cy="5029200"/>
+            <a:off x="457200" y="1280160"/>
+            <a:ext cx="11277295" cy="5120640"/>
           </a:xfrm>
           <a:prstGeom prst="rect">
             <a:avLst/>
@@ -5217,18 +5565,20 @@
               </a:spcAft>
             </a:pPr>
             <a:r>
-              <a:rPr b="1" sz="1800">
+              <a:rPr b="1" sz="1600">
                 <a:solidFill>
                   <a:srgbClr val="212529"/>
                 </a:solidFill>
+                <a:latin typeface="Arial"/>
               </a:rPr>
-              <a:t>GitHub Repository Link: </a:t>
-            </a:r>
-            <a:r>
-              <a:rPr sz="1800">
+              <a:t>Public GitHub Repository:</a:t>
+            </a:r>
+            <a:r>
+              <a:rPr sz="1600">
                 <a:solidFill>
                   <a:srgbClr val="212529"/>
                 </a:solidFill>
+                <a:latin typeface="Arial"/>
               </a:rPr>
               <a:t> https://github.com/ANSHKATIYARAK/semiconductor-hackathon.git</a:t>
             </a:r>
@@ -5240,43 +5590,113 @@
               </a:spcAft>
             </a:pPr>
             <a:r>
-              <a:rPr b="1" sz="1800">
+              <a:rPr b="1" sz="1600">
                 <a:solidFill>
                   <a:srgbClr val="212529"/>
                 </a:solidFill>
+                <a:latin typeface="Arial"/>
               </a:rPr>
-              <a:t>Model Checkpoint Download URL: </a:t>
-            </a:r>
-            <a:r>
-              <a:rPr sz="1800">
+              <a:t>Model Checkpoint:</a:t>
+            </a:r>
+            <a:r>
+              <a:rPr sz="1600">
                 <a:solidFill>
                   <a:srgbClr val="212529"/>
                 </a:solidFill>
+                <a:latin typeface="Arial"/>
               </a:rPr>
-              <a:t> Google Drive / Hugging Face weights download link is pinned in the repository README.md (Permissions: Anyone with link can view/download).</a:t>
+              <a:t> Public download link for best_model.pt embedded in repository README.md.</a:t>
             </a:r>
           </a:p>
           <a:p>
             <a:pPr>
               <a:spcAft>
-                <a:spcPts val="1200"/>
+                <a:spcPts val="800"/>
               </a:spcAft>
             </a:pPr>
             <a:r>
-              <a:rPr b="1" sz="1800">
+              <a:rPr b="1" sz="1600">
                 <a:solidFill>
                   <a:srgbClr val="212529"/>
                 </a:solidFill>
+                <a:latin typeface="Arial"/>
               </a:rPr>
-              <a:t>Deliverables Package Structure: </a:t>
-            </a:r>
-            <a:r>
-              <a:rPr sz="1800">
+              <a:t>Verified Deliverables Package (./submission_package/):</a:t>
+            </a:r>
+          </a:p>
+          <a:p>
+            <a:pPr lvl="1">
+              <a:spcAft>
+                <a:spcPts val="600"/>
+              </a:spcAft>
+            </a:pPr>
+            <a:r>
+              <a:rPr b="1" sz="1600">
                 <a:solidFill>
                   <a:srgbClr val="212529"/>
                 </a:solidFill>
+                <a:latin typeface="Arial"/>
               </a:rPr>
-              <a:t> Self-contained folder './submission_package/' contains:</a:t>
+              <a:t>• eval.py / eval_dun.py: </a:t>
+            </a:r>
+            <a:r>
+              <a:rPr sz="1600">
+                <a:solidFill>
+                  <a:srgbClr val="212529"/>
+                </a:solidFill>
+                <a:latin typeface="Arial"/>
+              </a:rPr>
+              <a:t>Standalone CLI supporting positional and flag arguments (--input_dir, --output_dir, --model_path).</a:t>
+            </a:r>
+          </a:p>
+          <a:p>
+            <a:pPr lvl="1">
+              <a:spcAft>
+                <a:spcPts val="600"/>
+              </a:spcAft>
+            </a:pPr>
+            <a:r>
+              <a:rPr b="1" sz="1600">
+                <a:solidFill>
+                  <a:srgbClr val="212529"/>
+                </a:solidFill>
+                <a:latin typeface="Arial"/>
+              </a:rPr>
+              <a:t>• train.py: </a:t>
+            </a:r>
+            <a:r>
+              <a:rPr sz="1600">
+                <a:solidFill>
+                  <a:srgbClr val="212529"/>
+                </a:solidFill>
+                <a:latin typeface="Arial"/>
+              </a:rPr>
+              <a:t>Full training pipeline with mixed precision and multi-loss objective.</a:t>
+            </a:r>
+          </a:p>
+          <a:p>
+            <a:pPr lvl="1">
+              <a:spcAft>
+                <a:spcPts val="600"/>
+              </a:spcAft>
+            </a:pPr>
+            <a:r>
+              <a:rPr b="1" sz="1600">
+                <a:solidFill>
+                  <a:srgbClr val="212529"/>
+                </a:solidFill>
+                <a:latin typeface="Arial"/>
+              </a:rPr>
+              <a:t>• test_predictions/: </a:t>
+            </a:r>
+            <a:r>
+              <a:rPr sz="1600">
+                <a:solidFill>
+                  <a:srgbClr val="212529"/>
+                </a:solidFill>
+                <a:latin typeface="Arial"/>
+              </a:rPr>
+              <a:t>400 verified .npy files (256x256, normalized strictly to [0.0, 1.0]).</a:t>
             </a:r>
           </a:p>
           <a:p>
@@ -5286,112 +5706,22 @@
               </a:spcAft>
             </a:pPr>
             <a:r>
-              <a:rPr b="1" sz="1800">
+              <a:rPr b="1" sz="1600">
                 <a:solidFill>
                   <a:srgbClr val="212529"/>
                 </a:solidFill>
+                <a:latin typeface="Arial"/>
               </a:rPr>
-              <a:t>- best_model.pt: </a:t>
-            </a:r>
-            <a:r>
-              <a:rPr sz="1800">
+              <a:t>• requirements.txt: </a:t>
+            </a:r>
+            <a:r>
+              <a:rPr sz="1600">
                 <a:solidFill>
                   <a:srgbClr val="212529"/>
                 </a:solidFill>
+                <a:latin typeface="Arial"/>
               </a:rPr>
-              <a:t> Trained parameter weights file (169.7 KB).</a:t>
-            </a:r>
-          </a:p>
-          <a:p>
-            <a:pPr lvl="1">
-              <a:spcAft>
-                <a:spcPts val="1200"/>
-              </a:spcAft>
-            </a:pPr>
-            <a:r>
-              <a:rPr b="1" sz="1800">
-                <a:solidFill>
-                  <a:srgbClr val="212529"/>
-                </a:solidFill>
-              </a:rPr>
-              <a:t>- eval.py / eval_dun.py: </a:t>
-            </a:r>
-            <a:r>
-              <a:rPr sz="1800">
-                <a:solidFill>
-                  <a:srgbClr val="212529"/>
-                </a:solidFill>
-              </a:rPr>
-              <a:t> Standalone evaluation CLI with positional and fallback parsing.</a:t>
-            </a:r>
-          </a:p>
-          <a:p>
-            <a:pPr lvl="1">
-              <a:spcAft>
-                <a:spcPts val="1200"/>
-              </a:spcAft>
-            </a:pPr>
-            <a:r>
-              <a:rPr b="1" sz="1800">
-                <a:solidFill>
-                  <a:srgbClr val="212529"/>
-                </a:solidFill>
-              </a:rPr>
-              <a:t>- model.onnx: </a:t>
-            </a:r>
-            <a:r>
-              <a:rPr sz="1800">
-                <a:solidFill>
-                  <a:srgbClr val="212529"/>
-                </a:solidFill>
-              </a:rPr>
-              <a:t> Ported ONNX model graph (430 KB).</a:t>
-            </a:r>
-          </a:p>
-          <a:p>
-            <a:pPr lvl="1">
-              <a:spcAft>
-                <a:spcPts val="1200"/>
-              </a:spcAft>
-            </a:pPr>
-            <a:r>
-              <a:rPr b="1" sz="1800">
-                <a:solidFill>
-                  <a:srgbClr val="212529"/>
-                </a:solidFill>
-              </a:rPr>
-              <a:t>- requirements.txt: </a:t>
-            </a:r>
-            <a:r>
-              <a:rPr sz="1800">
-                <a:solidFill>
-                  <a:srgbClr val="212529"/>
-                </a:solidFill>
-              </a:rPr>
-              <a:t> Pinned pip freeze environment requirements.</a:t>
-            </a:r>
-          </a:p>
-          <a:p>
-            <a:pPr>
-              <a:spcAft>
-                <a:spcPts val="1200"/>
-              </a:spcAft>
-            </a:pPr>
-            <a:r>
-              <a:rPr b="1" sz="1800">
-                <a:solidFill>
-                  <a:srgbClr val="212529"/>
-                </a:solidFill>
-              </a:rPr>
-              <a:t>Status: </a:t>
-            </a:r>
-            <a:r>
-              <a:rPr sz="1800">
-                <a:solidFill>
-                  <a:srgbClr val="212529"/>
-                </a:solidFill>
-              </a:rPr>
-              <a:t> Verified 400 predictions saved inside './test_predictions/' are shape-correct (256x256) and strictly bounded within [0.0, 1.0].</a:t>
+              <a:t>Environment specification file.</a:t>
             </a:r>
           </a:p>
         </p:txBody>

</xml_diff>